<commit_message>
updated component list and powerpoint
</commit_message>
<xml_diff>
--- a/Fall 2025/Aero Design 1/PowerPoint/SDR Presentation Template.pptx
+++ b/Fall 2025/Aero Design 1/PowerPoint/SDR Presentation Template.pptx
@@ -9,9 +9,10 @@
     <p:sldId id="262" r:id="rId3"/>
     <p:sldId id="267" r:id="rId4"/>
     <p:sldId id="268" r:id="rId5"/>
-    <p:sldId id="271" r:id="rId6"/>
-    <p:sldId id="270" r:id="rId7"/>
-    <p:sldId id="269" r:id="rId8"/>
+    <p:sldId id="272" r:id="rId6"/>
+    <p:sldId id="271" r:id="rId7"/>
+    <p:sldId id="270" r:id="rId8"/>
+    <p:sldId id="269" r:id="rId9"/>
   </p:sldIdLst>
   <p:sldSz cx="12192000" cy="6858000"/>
   <p:notesSz cx="6858000" cy="9144000"/>
@@ -303,7 +304,7 @@
           <a:p>
             <a:fld id="{3A332BE1-279E-4118-9FE3-7952B079A510}" type="datetimeFigureOut">
               <a:rPr lang="en-US" smtClean="0"/>
-              <a:t>10/1/2025</a:t>
+              <a:t>10/2/2025</a:t>
             </a:fld>
             <a:endParaRPr lang="en-US"/>
           </a:p>
@@ -532,7 +533,7 @@
           <a:p>
             <a:fld id="{F7E76D0F-5A12-4D0A-80B0-1A6122B61E7B}" type="datetimeFigureOut">
               <a:rPr lang="en-US" dirty="0"/>
-              <a:t>10/1/2025</a:t>
+              <a:t>10/2/2025</a:t>
             </a:fld>
             <a:endParaRPr lang="en-US"/>
           </a:p>
@@ -745,7 +746,7 @@
           <a:p>
             <a:fld id="{8B9E8C84-89CA-44AB-B0BE-5C91BAF75478}" type="datetimeFigureOut">
               <a:rPr lang="en-US" dirty="0"/>
-              <a:t>10/1/2025</a:t>
+              <a:t>10/2/2025</a:t>
             </a:fld>
             <a:endParaRPr lang="en-US"/>
           </a:p>
@@ -948,7 +949,7 @@
           <a:p>
             <a:fld id="{73E7156E-175E-4DBA-9D21-B772C320F342}" type="datetimeFigureOut">
               <a:rPr lang="en-US" dirty="0"/>
-              <a:t>10/1/2025</a:t>
+              <a:t>10/2/2025</a:t>
             </a:fld>
             <a:endParaRPr lang="en-US"/>
           </a:p>
@@ -1230,7 +1231,7 @@
           <a:p>
             <a:fld id="{04895F6E-3D02-4292-95D1-C62B3126321B}" type="datetimeFigureOut">
               <a:rPr lang="en-US" dirty="0"/>
-              <a:t>10/1/2025</a:t>
+              <a:t>10/2/2025</a:t>
             </a:fld>
             <a:endParaRPr lang="en-US"/>
           </a:p>
@@ -1505,7 +1506,7 @@
           <a:p>
             <a:fld id="{EDCB5ACB-D10C-44A8-9570-124370F4CB38}" type="datetimeFigureOut">
               <a:rPr lang="en-US" dirty="0"/>
-              <a:t>10/1/2025</a:t>
+              <a:t>10/2/2025</a:t>
             </a:fld>
             <a:endParaRPr lang="en-US"/>
           </a:p>
@@ -1932,7 +1933,7 @@
           <a:p>
             <a:fld id="{AB8D84F4-0E7A-4BDE-98C6-AE68FB974645}" type="datetimeFigureOut">
               <a:rPr lang="en-US" dirty="0"/>
-              <a:t>10/1/2025</a:t>
+              <a:t>10/2/2025</a:t>
             </a:fld>
             <a:endParaRPr lang="en-US"/>
           </a:p>
@@ -2078,7 +2079,7 @@
           <a:p>
             <a:fld id="{CBEFF1D8-9801-4C4B-92F3-66C9A863BD74}" type="datetimeFigureOut">
               <a:rPr lang="en-US" dirty="0"/>
-              <a:t>10/1/2025</a:t>
+              <a:t>10/2/2025</a:t>
             </a:fld>
             <a:endParaRPr lang="en-US"/>
           </a:p>
@@ -2196,7 +2197,7 @@
           <a:p>
             <a:fld id="{961FE8FD-B23E-4E1A-83EF-0847EBEA0105}" type="datetimeFigureOut">
               <a:rPr lang="en-US" dirty="0"/>
-              <a:t>10/1/2025</a:t>
+              <a:t>10/2/2025</a:t>
             </a:fld>
             <a:endParaRPr lang="en-US"/>
           </a:p>
@@ -2518,7 +2519,7 @@
           <a:p>
             <a:fld id="{8DDF891E-A7C2-465C-AD39-8EDCB0F58E3C}" type="datetimeFigureOut">
               <a:rPr lang="en-US" dirty="0"/>
-              <a:t>10/1/2025</a:t>
+              <a:t>10/2/2025</a:t>
             </a:fld>
             <a:endParaRPr lang="en-US"/>
           </a:p>
@@ -2813,7 +2814,7 @@
           <a:p>
             <a:fld id="{F39F93E5-AFB6-485C-8E3C-32F92A07875F}" type="datetimeFigureOut">
               <a:rPr lang="en-US" dirty="0"/>
-              <a:t>10/1/2025</a:t>
+              <a:t>10/2/2025</a:t>
             </a:fld>
             <a:endParaRPr lang="en-US"/>
           </a:p>
@@ -3057,7 +3058,7 @@
           <a:p>
             <a:fld id="{3A332BE1-279E-4118-9FE3-7952B079A510}" type="datetimeFigureOut">
               <a:rPr lang="en-US" dirty="0"/>
-              <a:t>10/1/2025</a:t>
+              <a:t>10/2/2025</a:t>
             </a:fld>
             <a:endParaRPr lang="en-US"/>
           </a:p>
@@ -4290,11 +4291,131 @@
         </p:spPr>
         <p:txBody>
           <a:bodyPr vert="horz" lIns="91440" tIns="45720" rIns="91440" bIns="45720" rtlCol="0" anchor="t">
-            <a:normAutofit/>
+            <a:normAutofit lnSpcReduction="10000"/>
           </a:bodyPr>
           <a:lstStyle/>
           <a:p>
-            <a:endParaRPr lang="en-US" dirty="0">
+            <a:r>
+              <a:rPr lang="en-US" sz="1400" dirty="0">
+                <a:latin typeface="Bierstadt"/>
+                <a:ea typeface="Calibri"/>
+                <a:cs typeface="Calibri"/>
+              </a:rPr>
+              <a:t>One onboard computer in the main satellite manages data handling, with a 64GB eMMC for buffering payload data prior to downlink.</a:t>
+            </a:r>
+          </a:p>
+          <a:p>
+            <a:r>
+              <a:rPr lang="en-US" sz="1400" dirty="0">
+                <a:latin typeface="Bierstadt"/>
+                <a:ea typeface="Calibri"/>
+                <a:cs typeface="Calibri"/>
+              </a:rPr>
+              <a:t>The communication system has dedicated subsystems for downlink, telemetry and command, and inter-sat links.</a:t>
+            </a:r>
+          </a:p>
+          <a:p>
+            <a:r>
+              <a:rPr lang="en-US" sz="1600" dirty="0">
+                <a:latin typeface="Bierstadt"/>
+                <a:ea typeface="Calibri"/>
+                <a:cs typeface="Calibri"/>
+              </a:rPr>
+              <a:t>Data Handling</a:t>
+            </a:r>
+          </a:p>
+          <a:p>
+            <a:pPr lvl="1"/>
+            <a:r>
+              <a:rPr lang="en-US" sz="1400" dirty="0">
+                <a:latin typeface="Bierstadt"/>
+                <a:ea typeface="Calibri"/>
+                <a:cs typeface="Calibri"/>
+              </a:rPr>
+              <a:t>Controlled by </a:t>
+            </a:r>
+            <a:r>
+              <a:rPr lang="en-US" sz="1400" dirty="0"/>
+              <a:t>STM32H723VET6 microcontroller.</a:t>
+            </a:r>
+          </a:p>
+          <a:p>
+            <a:pPr lvl="1"/>
+            <a:r>
+              <a:rPr lang="en-US" sz="1400" dirty="0">
+                <a:latin typeface="Bierstadt"/>
+                <a:ea typeface="Calibri"/>
+                <a:cs typeface="Calibri"/>
+              </a:rPr>
+              <a:t>Buffered on a SDINBDG4-64G-ZA3 eMMC.</a:t>
+            </a:r>
+          </a:p>
+          <a:p>
+            <a:r>
+              <a:rPr lang="en-US" sz="1600" dirty="0">
+                <a:latin typeface="Bierstadt"/>
+                <a:ea typeface="Calibri"/>
+                <a:cs typeface="Calibri"/>
+              </a:rPr>
+              <a:t>Payload Downlink</a:t>
+            </a:r>
+          </a:p>
+          <a:p>
+            <a:pPr lvl="1"/>
+            <a:r>
+              <a:rPr lang="en-US" sz="1400" dirty="0">
+                <a:latin typeface="Bierstadt"/>
+                <a:ea typeface="Calibri"/>
+                <a:cs typeface="Calibri"/>
+              </a:rPr>
+              <a:t>Downlink</a:t>
+            </a:r>
+          </a:p>
+          <a:p>
+            <a:r>
+              <a:rPr lang="en-US" sz="1600" dirty="0">
+                <a:latin typeface="Bierstadt"/>
+                <a:ea typeface="Calibri"/>
+                <a:cs typeface="Calibri"/>
+              </a:rPr>
+              <a:t>Telemetry &amp; Command</a:t>
+            </a:r>
+          </a:p>
+          <a:p>
+            <a:pPr lvl="1"/>
+            <a:r>
+              <a:rPr lang="en-US" sz="1400" dirty="0">
+                <a:latin typeface="Bierstadt"/>
+                <a:ea typeface="Calibri"/>
+                <a:cs typeface="Calibri"/>
+              </a:rPr>
+              <a:t>System</a:t>
+            </a:r>
+          </a:p>
+          <a:p>
+            <a:r>
+              <a:rPr lang="en-US" sz="1600" dirty="0">
+                <a:latin typeface="Bierstadt"/>
+                <a:ea typeface="Calibri"/>
+                <a:cs typeface="Calibri"/>
+              </a:rPr>
+              <a:t>Inter-Sat Communication</a:t>
+            </a:r>
+          </a:p>
+          <a:p>
+            <a:pPr lvl="1"/>
+            <a:r>
+              <a:rPr lang="en-US" sz="1400">
+                <a:latin typeface="Bierstadt"/>
+                <a:ea typeface="Calibri"/>
+                <a:cs typeface="Calibri"/>
+              </a:rPr>
+              <a:t>System</a:t>
+            </a:r>
+          </a:p>
+          <a:p>
+            <a:pPr lvl="1"/>
+            <a:endParaRPr lang="en-US" sz="1400" dirty="0">
               <a:latin typeface="Bierstadt"/>
               <a:ea typeface="Calibri"/>
               <a:cs typeface="Calibri"/>
@@ -4664,8 +4785,8 @@
           <a:lstStyle/>
           <a:p>
             <a:r>
-              <a:rPr lang="en-US"/>
-              <a:t>Table Template</a:t>
+              <a:rPr lang="en-US" dirty="0"/>
+              <a:t>Requirements</a:t>
             </a:r>
           </a:p>
         </p:txBody>
@@ -4981,11 +5102,17 @@
           <p:cNvGraphicFramePr>
             <a:graphicFrameLocks/>
           </p:cNvGraphicFramePr>
-          <p:nvPr/>
+          <p:nvPr>
+            <p:extLst>
+              <p:ext uri="{D42A27DB-BD31-4B8C-83A1-F6EECF244321}">
+                <p14:modId xmlns:p14="http://schemas.microsoft.com/office/powerpoint/2010/main" val="521582667"/>
+              </p:ext>
+            </p:extLst>
+          </p:nvPr>
         </p:nvGraphicFramePr>
         <p:xfrm>
           <a:off x="612775" y="1716088"/>
-          <a:ext cx="10653708" cy="2194560"/>
+          <a:ext cx="10653708" cy="3870960"/>
         </p:xfrm>
         <a:graphic>
           <a:graphicData uri="http://schemas.openxmlformats.org/drawingml/2006/table">
@@ -5043,7 +5170,11 @@
                     <a:bodyPr/>
                     <a:lstStyle/>
                     <a:p>
-                      <a:endParaRPr lang="en-US"/>
+                      <a:pPr algn="ctr"/>
+                      <a:r>
+                        <a:rPr lang="en-US" dirty="0"/>
+                        <a:t>Standard</a:t>
+                      </a:r>
                     </a:p>
                   </a:txBody>
                   <a:tcPr>
@@ -5057,7 +5188,11 @@
                     <a:bodyPr/>
                     <a:lstStyle/>
                     <a:p>
-                      <a:endParaRPr lang="en-US"/>
+                      <a:pPr algn="ctr"/>
+                      <a:r>
+                        <a:rPr lang="en-US" dirty="0"/>
+                        <a:t>Source</a:t>
+                      </a:r>
                     </a:p>
                   </a:txBody>
                   <a:tcPr>
@@ -5071,7 +5206,11 @@
                     <a:bodyPr/>
                     <a:lstStyle/>
                     <a:p>
-                      <a:endParaRPr lang="en-US"/>
+                      <a:pPr algn="ctr"/>
+                      <a:r>
+                        <a:rPr lang="en-US" dirty="0"/>
+                        <a:t>Name</a:t>
+                      </a:r>
                     </a:p>
                   </a:txBody>
                   <a:tcPr>
@@ -5085,7 +5224,11 @@
                     <a:bodyPr/>
                     <a:lstStyle/>
                     <a:p>
-                      <a:endParaRPr lang="en-US"/>
+                      <a:pPr algn="ctr"/>
+                      <a:r>
+                        <a:rPr lang="en-US" dirty="0"/>
+                        <a:t>Description</a:t>
+                      </a:r>
                     </a:p>
                   </a:txBody>
                   <a:tcPr>
@@ -5099,7 +5242,11 @@
                     <a:bodyPr/>
                     <a:lstStyle/>
                     <a:p>
-                      <a:endParaRPr lang="en-US"/>
+                      <a:pPr algn="ctr"/>
+                      <a:r>
+                        <a:rPr lang="en-US" dirty="0"/>
+                        <a:t>Supported By</a:t>
+                      </a:r>
                     </a:p>
                   </a:txBody>
                   <a:tcPr>
@@ -5113,7 +5260,11 @@
                     <a:bodyPr/>
                     <a:lstStyle/>
                     <a:p>
-                      <a:endParaRPr lang="en-US"/>
+                      <a:pPr algn="ctr"/>
+                      <a:r>
+                        <a:rPr lang="en-US" dirty="0"/>
+                        <a:t>Status</a:t>
+                      </a:r>
                     </a:p>
                   </a:txBody>
                   <a:tcPr>
@@ -5134,7 +5285,11 @@
                     <a:bodyPr/>
                     <a:lstStyle/>
                     <a:p>
-                      <a:endParaRPr lang="en-US"/>
+                      <a:pPr algn="ctr"/>
+                      <a:r>
+                        <a:rPr lang="en-US" dirty="0"/>
+                        <a:t>Give </a:t>
+                      </a:r>
                     </a:p>
                   </a:txBody>
                   <a:tcPr>
@@ -5148,7 +5303,11 @@
                     <a:bodyPr/>
                     <a:lstStyle/>
                     <a:p>
-                      <a:endParaRPr lang="en-US"/>
+                      <a:pPr algn="ctr"/>
+                      <a:r>
+                        <a:rPr lang="en-US" sz="1800" dirty="0"/>
+                        <a:t>EAS 4700 Project Requirements</a:t>
+                      </a:r>
                     </a:p>
                   </a:txBody>
                   <a:tcPr>
@@ -5162,7 +5321,11 @@
                     <a:bodyPr/>
                     <a:lstStyle/>
                     <a:p>
-                      <a:endParaRPr lang="en-US"/>
+                      <a:pPr algn="ctr"/>
+                      <a:r>
+                        <a:rPr lang="en-US" sz="1600" dirty="0"/>
+                        <a:t>Spacecraft Communication System</a:t>
+                      </a:r>
                     </a:p>
                   </a:txBody>
                   <a:tcPr>
@@ -5176,7 +5339,19 @@
                     <a:bodyPr/>
                     <a:lstStyle/>
                     <a:p>
-                      <a:endParaRPr lang="en-US"/>
+                      <a:pPr algn="ctr"/>
+                      <a:r>
+                        <a:rPr lang="en-US" sz="1100" dirty="0"/>
+                        <a:t>The GATOR-SAT </a:t>
+                      </a:r>
+                      <a:r>
+                        <a:rPr lang="en-US" sz="1100" dirty="0" err="1"/>
+                        <a:t>SmallSat</a:t>
+                      </a:r>
+                      <a:r>
+                        <a:rPr lang="en-US" sz="1100" dirty="0"/>
+                        <a:t> should be able to transmit and receive data such as position, health, and desired mission data to and from earth.</a:t>
+                      </a:r>
                     </a:p>
                   </a:txBody>
                   <a:tcPr>
@@ -5190,7 +5365,11 @@
                     <a:bodyPr/>
                     <a:lstStyle/>
                     <a:p>
-                      <a:endParaRPr lang="en-US"/>
+                      <a:pPr algn="ctr"/>
+                      <a:r>
+                        <a:rPr lang="en-US" sz="1100" dirty="0"/>
+                        <a:t>The S-Band antenna gives the transmitter and transceiver the ability to communicate with ground stations.</a:t>
+                      </a:r>
                     </a:p>
                   </a:txBody>
                   <a:tcPr>
@@ -5204,7 +5383,8 @@
                     <a:bodyPr/>
                     <a:lstStyle/>
                     <a:p>
-                      <a:endParaRPr lang="en-US"/>
+                      <a:pPr algn="ctr"/>
+                      <a:endParaRPr lang="en-US" dirty="0"/>
                     </a:p>
                   </a:txBody>
                   <a:tcPr>
@@ -5225,7 +5405,27 @@
                     <a:bodyPr/>
                     <a:lstStyle/>
                     <a:p>
-                      <a:endParaRPr lang="en-US"/>
+                      <a:pPr marL="0" marR="0" lvl="0" indent="0" algn="ctr" defTabSz="914400" rtl="0" eaLnBrk="1" fontAlgn="auto" latinLnBrk="0" hangingPunct="1">
+                        <a:lnSpc>
+                          <a:spcPct val="100000"/>
+                        </a:lnSpc>
+                        <a:spcBef>
+                          <a:spcPts val="0"/>
+                        </a:spcBef>
+                        <a:spcAft>
+                          <a:spcPts val="0"/>
+                        </a:spcAft>
+                        <a:buClrTx/>
+                        <a:buSzTx/>
+                        <a:buFontTx/>
+                        <a:buNone/>
+                        <a:tabLst/>
+                        <a:defRPr/>
+                      </a:pPr>
+                      <a:r>
+                        <a:rPr lang="en-US" dirty="0"/>
+                        <a:t>ASD-GTRS-02</a:t>
+                      </a:r>
                     </a:p>
                   </a:txBody>
                   <a:tcPr/>
@@ -5235,7 +5435,27 @@
                     <a:bodyPr/>
                     <a:lstStyle/>
                     <a:p>
-                      <a:endParaRPr lang="en-US"/>
+                      <a:pPr marL="0" marR="0" lvl="0" indent="0" algn="ctr" defTabSz="914400" rtl="0" eaLnBrk="1" fontAlgn="auto" latinLnBrk="0" hangingPunct="1">
+                        <a:lnSpc>
+                          <a:spcPct val="100000"/>
+                        </a:lnSpc>
+                        <a:spcBef>
+                          <a:spcPts val="0"/>
+                        </a:spcBef>
+                        <a:spcAft>
+                          <a:spcPts val="0"/>
+                        </a:spcAft>
+                        <a:buClrTx/>
+                        <a:buSzTx/>
+                        <a:buFontTx/>
+                        <a:buNone/>
+                        <a:tabLst/>
+                        <a:defRPr/>
+                      </a:pPr>
+                      <a:r>
+                        <a:rPr lang="en-US" sz="1800" dirty="0"/>
+                        <a:t>EAS 4700 Project Requirements</a:t>
+                      </a:r>
                     </a:p>
                   </a:txBody>
                   <a:tcPr/>
@@ -5245,7 +5465,15 @@
                     <a:bodyPr/>
                     <a:lstStyle/>
                     <a:p>
-                      <a:endParaRPr lang="en-US"/>
+                      <a:pPr algn="ctr"/>
+                      <a:r>
+                        <a:rPr lang="en-US" sz="1600" dirty="0" err="1"/>
+                        <a:t>InterSat</a:t>
+                      </a:r>
+                      <a:r>
+                        <a:rPr lang="en-US" sz="1600" dirty="0"/>
+                        <a:t> Communication System</a:t>
+                      </a:r>
                     </a:p>
                   </a:txBody>
                   <a:tcPr/>
@@ -5255,7 +5483,19 @@
                     <a:bodyPr/>
                     <a:lstStyle/>
                     <a:p>
-                      <a:endParaRPr lang="en-US"/>
+                      <a:pPr algn="ctr"/>
+                      <a:r>
+                        <a:rPr lang="en-US" sz="1100" dirty="0"/>
+                        <a:t>The GATOR-SAT </a:t>
+                      </a:r>
+                      <a:r>
+                        <a:rPr lang="en-US" sz="1100" dirty="0" err="1"/>
+                        <a:t>SmallSat</a:t>
+                      </a:r>
+                      <a:r>
+                        <a:rPr lang="en-US" sz="1100" dirty="0"/>
+                        <a:t> must be able to send commands and data between the two Sats.</a:t>
+                      </a:r>
                     </a:p>
                   </a:txBody>
                   <a:tcPr/>
@@ -5265,7 +5505,11 @@
                     <a:bodyPr/>
                     <a:lstStyle/>
                     <a:p>
-                      <a:endParaRPr lang="en-US"/>
+                      <a:pPr algn="ctr"/>
+                      <a:r>
+                        <a:rPr lang="en-US" sz="1100" dirty="0"/>
+                        <a:t>The UHF antennas on both Sats can send necessary data back and forth to one another.</a:t>
+                      </a:r>
                     </a:p>
                   </a:txBody>
                   <a:tcPr/>
@@ -5275,6 +5519,7 @@
                     <a:bodyPr/>
                     <a:lstStyle/>
                     <a:p>
+                      <a:pPr algn="ctr"/>
                       <a:endParaRPr lang="en-US"/>
                     </a:p>
                   </a:txBody>
@@ -5292,7 +5537,31 @@
                     <a:bodyPr/>
                     <a:lstStyle/>
                     <a:p>
-                      <a:endParaRPr lang="en-US"/>
+                      <a:pPr marL="0" marR="0" lvl="0" indent="0" algn="ctr" defTabSz="914400" rtl="0" eaLnBrk="1" fontAlgn="auto" latinLnBrk="0" hangingPunct="1">
+                        <a:lnSpc>
+                          <a:spcPct val="100000"/>
+                        </a:lnSpc>
+                        <a:spcBef>
+                          <a:spcPts val="0"/>
+                        </a:spcBef>
+                        <a:spcAft>
+                          <a:spcPts val="0"/>
+                        </a:spcAft>
+                        <a:buClrTx/>
+                        <a:buSzTx/>
+                        <a:buFontTx/>
+                        <a:buNone/>
+                        <a:tabLst/>
+                        <a:defRPr/>
+                      </a:pPr>
+                      <a:r>
+                        <a:rPr lang="en-US" dirty="0"/>
+                        <a:t>COM-GTRS-03</a:t>
+                      </a:r>
+                    </a:p>
+                    <a:p>
+                      <a:pPr algn="ctr"/>
+                      <a:endParaRPr lang="en-US" dirty="0"/>
                     </a:p>
                   </a:txBody>
                   <a:tcPr>
@@ -5306,7 +5575,15 @@
                     <a:bodyPr/>
                     <a:lstStyle/>
                     <a:p>
-                      <a:endParaRPr lang="en-US"/>
+                      <a:pPr algn="ctr"/>
+                      <a:r>
+                        <a:rPr lang="en-US" dirty="0"/>
+                        <a:t>COM-GTRS-01</a:t>
+                      </a:r>
+                    </a:p>
+                    <a:p>
+                      <a:pPr algn="ctr"/>
+                      <a:endParaRPr lang="en-US" dirty="0"/>
                     </a:p>
                   </a:txBody>
                   <a:tcPr>
@@ -5320,7 +5597,11 @@
                     <a:bodyPr/>
                     <a:lstStyle/>
                     <a:p>
-                      <a:endParaRPr lang="en-US"/>
+                      <a:pPr algn="ctr"/>
+                      <a:r>
+                        <a:rPr lang="en-US" dirty="0"/>
+                        <a:t>Downlink Data System</a:t>
+                      </a:r>
                     </a:p>
                   </a:txBody>
                   <a:tcPr>
@@ -5334,7 +5615,19 @@
                     <a:bodyPr/>
                     <a:lstStyle/>
                     <a:p>
-                      <a:endParaRPr lang="en-US"/>
+                      <a:pPr algn="ctr"/>
+                      <a:r>
+                        <a:rPr lang="en-US" sz="1100" dirty="0"/>
+                        <a:t>The GATOR-Sat </a:t>
+                      </a:r>
+                      <a:r>
+                        <a:rPr lang="en-US" sz="1100" dirty="0" err="1"/>
+                        <a:t>SmallSat</a:t>
+                      </a:r>
+                      <a:r>
+                        <a:rPr lang="en-US" sz="1100" dirty="0"/>
+                        <a:t> must be able to provide access to experimental data regularly</a:t>
+                      </a:r>
                     </a:p>
                   </a:txBody>
                   <a:tcPr>
@@ -5348,7 +5641,11 @@
                     <a:bodyPr/>
                     <a:lstStyle/>
                     <a:p>
-                      <a:endParaRPr lang="en-US"/>
+                      <a:pPr algn="ctr"/>
+                      <a:r>
+                        <a:rPr lang="en-US" sz="1100" dirty="0"/>
+                        <a:t>The chose S-Band transceiver allows high data transfer which meets this requirement.</a:t>
+                      </a:r>
                     </a:p>
                   </a:txBody>
                   <a:tcPr>
@@ -5362,6 +5659,7 @@
                     <a:bodyPr/>
                     <a:lstStyle/>
                     <a:p>
+                      <a:pPr algn="ctr"/>
                       <a:endParaRPr lang="en-US"/>
                     </a:p>
                   </a:txBody>
@@ -5383,6 +5681,7 @@
                     <a:bodyPr/>
                     <a:lstStyle/>
                     <a:p>
+                      <a:pPr algn="ctr"/>
                       <a:endParaRPr lang="en-US"/>
                     </a:p>
                   </a:txBody>
@@ -5393,6 +5692,7 @@
                     <a:bodyPr/>
                     <a:lstStyle/>
                     <a:p>
+                      <a:pPr algn="ctr"/>
                       <a:endParaRPr lang="en-US"/>
                     </a:p>
                   </a:txBody>
@@ -5403,6 +5703,7 @@
                     <a:bodyPr/>
                     <a:lstStyle/>
                     <a:p>
+                      <a:pPr algn="ctr"/>
                       <a:endParaRPr lang="en-US"/>
                     </a:p>
                   </a:txBody>
@@ -5413,6 +5714,7 @@
                     <a:bodyPr/>
                     <a:lstStyle/>
                     <a:p>
+                      <a:pPr algn="ctr"/>
                       <a:endParaRPr lang="en-US"/>
                     </a:p>
                   </a:txBody>
@@ -5423,6 +5725,7 @@
                     <a:bodyPr/>
                     <a:lstStyle/>
                     <a:p>
+                      <a:pPr algn="ctr"/>
                       <a:endParaRPr lang="en-US"/>
                     </a:p>
                   </a:txBody>
@@ -5433,6 +5736,7 @@
                     <a:bodyPr/>
                     <a:lstStyle/>
                     <a:p>
+                      <a:pPr algn="ctr"/>
                       <a:endParaRPr lang="en-US"/>
                     </a:p>
                   </a:txBody>
@@ -5450,6 +5754,7 @@
                     <a:bodyPr/>
                     <a:lstStyle/>
                     <a:p>
+                      <a:pPr algn="ctr"/>
                       <a:endParaRPr lang="en-US"/>
                     </a:p>
                   </a:txBody>
@@ -5464,6 +5769,7 @@
                     <a:bodyPr/>
                     <a:lstStyle/>
                     <a:p>
+                      <a:pPr algn="ctr"/>
                       <a:endParaRPr lang="en-US"/>
                     </a:p>
                   </a:txBody>
@@ -5478,6 +5784,7 @@
                     <a:bodyPr/>
                     <a:lstStyle/>
                     <a:p>
+                      <a:pPr algn="ctr"/>
                       <a:endParaRPr lang="en-US"/>
                     </a:p>
                   </a:txBody>
@@ -5492,6 +5799,7 @@
                     <a:bodyPr/>
                     <a:lstStyle/>
                     <a:p>
+                      <a:pPr algn="ctr"/>
                       <a:endParaRPr lang="en-US"/>
                     </a:p>
                   </a:txBody>
@@ -5506,6 +5814,7 @@
                     <a:bodyPr/>
                     <a:lstStyle/>
                     <a:p>
+                      <a:pPr algn="ctr"/>
                       <a:endParaRPr lang="en-US"/>
                     </a:p>
                   </a:txBody>
@@ -5520,7 +5829,8 @@
                     <a:bodyPr/>
                     <a:lstStyle/>
                     <a:p>
-                      <a:endParaRPr lang="en-US"/>
+                      <a:pPr algn="ctr"/>
+                      <a:endParaRPr lang="en-US" dirty="0"/>
                     </a:p>
                   </a:txBody>
                   <a:tcPr>
@@ -5553,6 +5863,1121 @@
 </file>
 
 <file path=ppt/slides/slide5.xml><?xml version="1.0" encoding="utf-8"?>
+<p:sld xmlns:a="http://schemas.openxmlformats.org/drawingml/2006/main" xmlns:r="http://schemas.openxmlformats.org/officeDocument/2006/relationships" xmlns:p="http://schemas.openxmlformats.org/presentationml/2006/main">
+  <p:cSld>
+    <p:spTree>
+      <p:nvGrpSpPr>
+        <p:cNvPr id="1" name="">
+          <a:extLst>
+            <a:ext uri="{FF2B5EF4-FFF2-40B4-BE49-F238E27FC236}">
+              <a16:creationId xmlns:a16="http://schemas.microsoft.com/office/drawing/2014/main" id="{C48C66E8-30B1-7A8A-80F5-8E31C70428A7}"/>
+            </a:ext>
+          </a:extLst>
+        </p:cNvPr>
+        <p:cNvGrpSpPr/>
+        <p:nvPr/>
+      </p:nvGrpSpPr>
+      <p:grpSpPr>
+        <a:xfrm>
+          <a:off x="0" y="0"/>
+          <a:ext cx="0" cy="0"/>
+          <a:chOff x="0" y="0"/>
+          <a:chExt cx="0" cy="0"/>
+        </a:xfrm>
+      </p:grpSpPr>
+      <p:sp>
+        <p:nvSpPr>
+          <p:cNvPr id="2" name="Title 1">
+            <a:extLst>
+              <a:ext uri="{FF2B5EF4-FFF2-40B4-BE49-F238E27FC236}">
+                <a16:creationId xmlns:a16="http://schemas.microsoft.com/office/drawing/2014/main" id="{C1EB1C14-F813-0542-072F-BEE89E4D3EBB}"/>
+              </a:ext>
+            </a:extLst>
+          </p:cNvPr>
+          <p:cNvSpPr>
+            <a:spLocks noGrp="1"/>
+          </p:cNvSpPr>
+          <p:nvPr>
+            <p:ph type="title"/>
+          </p:nvPr>
+        </p:nvSpPr>
+        <p:spPr>
+          <a:xfrm>
+            <a:off x="612648" y="403497"/>
+            <a:ext cx="10653578" cy="1132258"/>
+          </a:xfrm>
+        </p:spPr>
+        <p:txBody>
+          <a:bodyPr/>
+          <a:lstStyle/>
+          <a:p>
+            <a:r>
+              <a:rPr lang="en-US"/>
+              <a:t>Table Template</a:t>
+            </a:r>
+          </a:p>
+        </p:txBody>
+      </p:sp>
+      <p:pic>
+        <p:nvPicPr>
+          <p:cNvPr id="9" name="Picture 8" descr="A logo of a planet&#10;&#10;AI-generated content may be incorrect.">
+            <a:extLst>
+              <a:ext uri="{FF2B5EF4-FFF2-40B4-BE49-F238E27FC236}">
+                <a16:creationId xmlns:a16="http://schemas.microsoft.com/office/drawing/2014/main" id="{21C9BFF6-5B8F-9368-222C-191C605A8D54}"/>
+              </a:ext>
+            </a:extLst>
+          </p:cNvPr>
+          <p:cNvPicPr>
+            <a:picLocks noChangeAspect="1"/>
+          </p:cNvPicPr>
+          <p:nvPr/>
+        </p:nvPicPr>
+        <p:blipFill>
+          <a:blip r:embed="rId2"/>
+          <a:stretch>
+            <a:fillRect/>
+          </a:stretch>
+        </p:blipFill>
+        <p:spPr>
+          <a:xfrm>
+            <a:off x="10610540" y="196315"/>
+            <a:ext cx="1293894" cy="1288609"/>
+          </a:xfrm>
+          <a:prstGeom prst="rect">
+            <a:avLst/>
+          </a:prstGeom>
+        </p:spPr>
+      </p:pic>
+      <p:cxnSp>
+        <p:nvCxnSpPr>
+          <p:cNvPr id="10" name="Straight Arrow Connector 9">
+            <a:extLst>
+              <a:ext uri="{FF2B5EF4-FFF2-40B4-BE49-F238E27FC236}">
+                <a16:creationId xmlns:a16="http://schemas.microsoft.com/office/drawing/2014/main" id="{D93E29AB-3A55-96B8-D643-7D4D184CEE3B}"/>
+              </a:ext>
+            </a:extLst>
+          </p:cNvPr>
+          <p:cNvCxnSpPr/>
+          <p:nvPr/>
+        </p:nvCxnSpPr>
+        <p:spPr>
+          <a:xfrm flipV="1">
+            <a:off x="526142" y="1094617"/>
+            <a:ext cx="9748761" cy="30239"/>
+          </a:xfrm>
+          <a:prstGeom prst="straightConnector1">
+            <a:avLst/>
+          </a:prstGeom>
+          <a:ln>
+            <a:solidFill>
+              <a:srgbClr val="0070C0"/>
+            </a:solidFill>
+          </a:ln>
+        </p:spPr>
+        <p:style>
+          <a:lnRef idx="3">
+            <a:schemeClr val="accent1"/>
+          </a:lnRef>
+          <a:fillRef idx="0">
+            <a:schemeClr val="accent1"/>
+          </a:fillRef>
+          <a:effectRef idx="2">
+            <a:schemeClr val="accent1"/>
+          </a:effectRef>
+          <a:fontRef idx="minor">
+            <a:schemeClr val="tx1"/>
+          </a:fontRef>
+        </p:style>
+      </p:cxnSp>
+      <p:sp>
+        <p:nvSpPr>
+          <p:cNvPr id="11" name="TextBox 10">
+            <a:extLst>
+              <a:ext uri="{FF2B5EF4-FFF2-40B4-BE49-F238E27FC236}">
+                <a16:creationId xmlns:a16="http://schemas.microsoft.com/office/drawing/2014/main" id="{C825C826-B380-9A4A-BE71-09F1659F92AA}"/>
+              </a:ext>
+            </a:extLst>
+          </p:cNvPr>
+          <p:cNvSpPr txBox="1"/>
+          <p:nvPr/>
+        </p:nvSpPr>
+        <p:spPr>
+          <a:xfrm>
+            <a:off x="3190350" y="6440249"/>
+            <a:ext cx="5811296" cy="369332"/>
+          </a:xfrm>
+          <a:prstGeom prst="rect">
+            <a:avLst/>
+          </a:prstGeom>
+          <a:noFill/>
+        </p:spPr>
+        <p:txBody>
+          <a:bodyPr rot="0" spcFirstLastPara="0" vertOverflow="overflow" horzOverflow="overflow" vert="horz" wrap="square" lIns="91440" tIns="45720" rIns="91440" bIns="45720" numCol="1" spcCol="0" rtlCol="0" fromWordArt="0" anchor="t" anchorCtr="0" forceAA="0" compatLnSpc="1">
+            <a:prstTxWarp prst="textNoShape">
+              <a:avLst/>
+            </a:prstTxWarp>
+            <a:spAutoFit/>
+          </a:bodyPr>
+          <a:lstStyle/>
+          <a:p>
+            <a:pPr algn="ctr"/>
+            <a:r>
+              <a:rPr lang="en-US" b="1">
+                <a:solidFill>
+                  <a:schemeClr val="bg1">
+                    <a:lumMod val="49000"/>
+                  </a:schemeClr>
+                </a:solidFill>
+                <a:latin typeface="Bierstadt"/>
+              </a:rPr>
+              <a:t>Name - Email</a:t>
+            </a:r>
+            <a:endParaRPr lang="en-US">
+              <a:solidFill>
+                <a:schemeClr val="bg1">
+                  <a:lumMod val="49000"/>
+                </a:schemeClr>
+              </a:solidFill>
+            </a:endParaRPr>
+          </a:p>
+        </p:txBody>
+      </p:sp>
+      <p:cxnSp>
+        <p:nvCxnSpPr>
+          <p:cNvPr id="4" name="Straight Arrow Connector 3">
+            <a:extLst>
+              <a:ext uri="{FF2B5EF4-FFF2-40B4-BE49-F238E27FC236}">
+                <a16:creationId xmlns:a16="http://schemas.microsoft.com/office/drawing/2014/main" id="{F10CE524-985D-A212-4CBE-D991CA1DE60F}"/>
+              </a:ext>
+            </a:extLst>
+          </p:cNvPr>
+          <p:cNvCxnSpPr>
+            <a:cxnSpLocks/>
+          </p:cNvCxnSpPr>
+          <p:nvPr/>
+        </p:nvCxnSpPr>
+        <p:spPr>
+          <a:xfrm>
+            <a:off x="526141" y="6362093"/>
+            <a:ext cx="11151808" cy="18141"/>
+          </a:xfrm>
+          <a:prstGeom prst="straightConnector1">
+            <a:avLst/>
+          </a:prstGeom>
+          <a:ln>
+            <a:solidFill>
+              <a:srgbClr val="0070C0"/>
+            </a:solidFill>
+          </a:ln>
+        </p:spPr>
+        <p:style>
+          <a:lnRef idx="3">
+            <a:schemeClr val="accent1"/>
+          </a:lnRef>
+          <a:fillRef idx="0">
+            <a:schemeClr val="accent1"/>
+          </a:fillRef>
+          <a:effectRef idx="2">
+            <a:schemeClr val="accent1"/>
+          </a:effectRef>
+          <a:fontRef idx="minor">
+            <a:schemeClr val="tx1"/>
+          </a:fontRef>
+        </p:style>
+      </p:cxnSp>
+      <p:sp>
+        <p:nvSpPr>
+          <p:cNvPr id="7" name="Slide Number Placeholder 6">
+            <a:extLst>
+              <a:ext uri="{FF2B5EF4-FFF2-40B4-BE49-F238E27FC236}">
+                <a16:creationId xmlns:a16="http://schemas.microsoft.com/office/drawing/2014/main" id="{2CA22233-1AAB-C5A7-CE99-8496CC9262E4}"/>
+              </a:ext>
+            </a:extLst>
+          </p:cNvPr>
+          <p:cNvSpPr>
+            <a:spLocks noGrp="1"/>
+          </p:cNvSpPr>
+          <p:nvPr>
+            <p:ph type="sldNum" sz="quarter" idx="12"/>
+          </p:nvPr>
+        </p:nvSpPr>
+        <p:spPr/>
+        <p:txBody>
+          <a:bodyPr/>
+          <a:lstStyle/>
+          <a:p>
+            <a:fld id="{CC057153-B650-4DEB-B370-79DDCFDCE934}" type="slidenum">
+              <a:rPr lang="en-US" dirty="0"/>
+              <a:t>5</a:t>
+            </a:fld>
+            <a:endParaRPr lang="en-US"/>
+          </a:p>
+        </p:txBody>
+      </p:sp>
+      <p:sp>
+        <p:nvSpPr>
+          <p:cNvPr id="8" name="TextBox 7">
+            <a:extLst>
+              <a:ext uri="{FF2B5EF4-FFF2-40B4-BE49-F238E27FC236}">
+                <a16:creationId xmlns:a16="http://schemas.microsoft.com/office/drawing/2014/main" id="{E9B722C0-FCCC-60A9-1081-9D8C2DCC162E}"/>
+              </a:ext>
+            </a:extLst>
+          </p:cNvPr>
+          <p:cNvSpPr txBox="1"/>
+          <p:nvPr/>
+        </p:nvSpPr>
+        <p:spPr>
+          <a:xfrm>
+            <a:off x="611347" y="6442164"/>
+            <a:ext cx="4138811" cy="369332"/>
+          </a:xfrm>
+          <a:prstGeom prst="rect">
+            <a:avLst/>
+          </a:prstGeom>
+          <a:noFill/>
+        </p:spPr>
+        <p:txBody>
+          <a:bodyPr rot="0" spcFirstLastPara="0" vertOverflow="overflow" horzOverflow="overflow" vert="horz" wrap="square" lIns="91440" tIns="45720" rIns="91440" bIns="45720" numCol="1" spcCol="0" rtlCol="0" fromWordArt="0" anchor="t" anchorCtr="0" forceAA="0" compatLnSpc="1">
+            <a:prstTxWarp prst="textNoShape">
+              <a:avLst/>
+            </a:prstTxWarp>
+            <a:spAutoFit/>
+          </a:bodyPr>
+          <a:lstStyle/>
+          <a:p>
+            <a:r>
+              <a:rPr lang="en-US">
+                <a:solidFill>
+                  <a:schemeClr val="bg1">
+                    <a:lumMod val="49000"/>
+                  </a:schemeClr>
+                </a:solidFill>
+                <a:latin typeface="Bierstadt Bold"/>
+              </a:rPr>
+              <a:t>10/09/25</a:t>
+            </a:r>
+            <a:r>
+              <a:rPr lang="en-US">
+                <a:latin typeface="Bierstadt Bold"/>
+              </a:rPr>
+              <a:t>  </a:t>
+            </a:r>
+          </a:p>
+        </p:txBody>
+      </p:sp>
+      <p:sp>
+        <p:nvSpPr>
+          <p:cNvPr id="5" name="TextBox 4">
+            <a:extLst>
+              <a:ext uri="{FF2B5EF4-FFF2-40B4-BE49-F238E27FC236}">
+                <a16:creationId xmlns:a16="http://schemas.microsoft.com/office/drawing/2014/main" id="{6CFCD2A7-08AE-26A6-AE84-79D127A82480}"/>
+              </a:ext>
+            </a:extLst>
+          </p:cNvPr>
+          <p:cNvSpPr txBox="1"/>
+          <p:nvPr/>
+        </p:nvSpPr>
+        <p:spPr>
+          <a:xfrm>
+            <a:off x="9638323" y="6443785"/>
+            <a:ext cx="2743200" cy="369332"/>
+          </a:xfrm>
+          <a:prstGeom prst="rect">
+            <a:avLst/>
+          </a:prstGeom>
+          <a:noFill/>
+        </p:spPr>
+        <p:txBody>
+          <a:bodyPr rot="0" spcFirstLastPara="0" vertOverflow="overflow" horzOverflow="overflow" vert="horz" wrap="square" lIns="91440" tIns="45720" rIns="91440" bIns="45720" numCol="1" spcCol="0" rtlCol="0" fromWordArt="0" anchor="t" anchorCtr="0" forceAA="0" compatLnSpc="1">
+            <a:prstTxWarp prst="textNoShape">
+              <a:avLst/>
+            </a:prstTxWarp>
+            <a:spAutoFit/>
+          </a:bodyPr>
+          <a:lstStyle/>
+          <a:p>
+            <a:r>
+              <a:rPr lang="en-US">
+                <a:solidFill>
+                  <a:schemeClr val="bg1">
+                    <a:lumMod val="49000"/>
+                  </a:schemeClr>
+                </a:solidFill>
+                <a:latin typeface="Bierstadt Bold"/>
+              </a:rPr>
+              <a:t>TANGO SDR​ - UF</a:t>
+            </a:r>
+            <a:endParaRPr lang="en-US">
+              <a:solidFill>
+                <a:schemeClr val="bg1">
+                  <a:lumMod val="49000"/>
+                </a:schemeClr>
+              </a:solidFill>
+            </a:endParaRPr>
+          </a:p>
+        </p:txBody>
+      </p:sp>
+      <p:graphicFrame>
+        <p:nvGraphicFramePr>
+          <p:cNvPr id="12" name="Content Placeholder 4">
+            <a:extLst>
+              <a:ext uri="{FF2B5EF4-FFF2-40B4-BE49-F238E27FC236}">
+                <a16:creationId xmlns:a16="http://schemas.microsoft.com/office/drawing/2014/main" id="{AE62062F-6DA5-FEFA-CE18-FC56ADC15D4E}"/>
+              </a:ext>
+            </a:extLst>
+          </p:cNvPr>
+          <p:cNvGraphicFramePr>
+            <a:graphicFrameLocks/>
+          </p:cNvGraphicFramePr>
+          <p:nvPr/>
+        </p:nvGraphicFramePr>
+        <p:xfrm>
+          <a:off x="612775" y="1716088"/>
+          <a:ext cx="10653708" cy="4038600"/>
+        </p:xfrm>
+        <a:graphic>
+          <a:graphicData uri="http://schemas.openxmlformats.org/drawingml/2006/table">
+            <a:tbl>
+              <a:tblPr firstRow="1" bandRow="1">
+                <a:tableStyleId>{5C22544A-7EE6-4342-B048-85BDC9FD1C3A}</a:tableStyleId>
+              </a:tblPr>
+              <a:tblGrid>
+                <a:gridCol w="1775618">
+                  <a:extLst>
+                    <a:ext uri="{9D8B030D-6E8A-4147-A177-3AD203B41FA5}">
+                      <a16:colId xmlns:a16="http://schemas.microsoft.com/office/drawing/2014/main" val="3098987667"/>
+                    </a:ext>
+                  </a:extLst>
+                </a:gridCol>
+                <a:gridCol w="1775618">
+                  <a:extLst>
+                    <a:ext uri="{9D8B030D-6E8A-4147-A177-3AD203B41FA5}">
+                      <a16:colId xmlns:a16="http://schemas.microsoft.com/office/drawing/2014/main" val="3687653135"/>
+                    </a:ext>
+                  </a:extLst>
+                </a:gridCol>
+                <a:gridCol w="1775618">
+                  <a:extLst>
+                    <a:ext uri="{9D8B030D-6E8A-4147-A177-3AD203B41FA5}">
+                      <a16:colId xmlns:a16="http://schemas.microsoft.com/office/drawing/2014/main" val="908228730"/>
+                    </a:ext>
+                  </a:extLst>
+                </a:gridCol>
+                <a:gridCol w="1775618">
+                  <a:extLst>
+                    <a:ext uri="{9D8B030D-6E8A-4147-A177-3AD203B41FA5}">
+                      <a16:colId xmlns:a16="http://schemas.microsoft.com/office/drawing/2014/main" val="3533606866"/>
+                    </a:ext>
+                  </a:extLst>
+                </a:gridCol>
+                <a:gridCol w="1775618">
+                  <a:extLst>
+                    <a:ext uri="{9D8B030D-6E8A-4147-A177-3AD203B41FA5}">
+                      <a16:colId xmlns:a16="http://schemas.microsoft.com/office/drawing/2014/main" val="2473987835"/>
+                    </a:ext>
+                  </a:extLst>
+                </a:gridCol>
+                <a:gridCol w="1775618">
+                  <a:extLst>
+                    <a:ext uri="{9D8B030D-6E8A-4147-A177-3AD203B41FA5}">
+                      <a16:colId xmlns:a16="http://schemas.microsoft.com/office/drawing/2014/main" val="330848909"/>
+                    </a:ext>
+                  </a:extLst>
+                </a:gridCol>
+              </a:tblGrid>
+              <a:tr h="363062">
+                <a:tc>
+                  <a:txBody>
+                    <a:bodyPr/>
+                    <a:lstStyle/>
+                    <a:p>
+                      <a:pPr algn="ctr"/>
+                      <a:r>
+                        <a:rPr lang="en-US" dirty="0"/>
+                        <a:t>Standard</a:t>
+                      </a:r>
+                    </a:p>
+                  </a:txBody>
+                  <a:tcPr>
+                    <a:solidFill>
+                      <a:srgbClr val="0070C0"/>
+                    </a:solidFill>
+                  </a:tcPr>
+                </a:tc>
+                <a:tc>
+                  <a:txBody>
+                    <a:bodyPr/>
+                    <a:lstStyle/>
+                    <a:p>
+                      <a:pPr algn="ctr"/>
+                      <a:r>
+                        <a:rPr lang="en-US" dirty="0"/>
+                        <a:t>Source</a:t>
+                      </a:r>
+                    </a:p>
+                  </a:txBody>
+                  <a:tcPr>
+                    <a:solidFill>
+                      <a:srgbClr val="0070C0"/>
+                    </a:solidFill>
+                  </a:tcPr>
+                </a:tc>
+                <a:tc>
+                  <a:txBody>
+                    <a:bodyPr/>
+                    <a:lstStyle/>
+                    <a:p>
+                      <a:pPr algn="ctr"/>
+                      <a:r>
+                        <a:rPr lang="en-US" dirty="0"/>
+                        <a:t>Name</a:t>
+                      </a:r>
+                    </a:p>
+                  </a:txBody>
+                  <a:tcPr>
+                    <a:solidFill>
+                      <a:srgbClr val="0070C0"/>
+                    </a:solidFill>
+                  </a:tcPr>
+                </a:tc>
+                <a:tc>
+                  <a:txBody>
+                    <a:bodyPr/>
+                    <a:lstStyle/>
+                    <a:p>
+                      <a:pPr algn="ctr"/>
+                      <a:r>
+                        <a:rPr lang="en-US" dirty="0"/>
+                        <a:t>Description</a:t>
+                      </a:r>
+                    </a:p>
+                  </a:txBody>
+                  <a:tcPr>
+                    <a:solidFill>
+                      <a:srgbClr val="0070C0"/>
+                    </a:solidFill>
+                  </a:tcPr>
+                </a:tc>
+                <a:tc>
+                  <a:txBody>
+                    <a:bodyPr/>
+                    <a:lstStyle/>
+                    <a:p>
+                      <a:pPr algn="ctr"/>
+                      <a:r>
+                        <a:rPr lang="en-US" dirty="0"/>
+                        <a:t>Supported By</a:t>
+                      </a:r>
+                    </a:p>
+                  </a:txBody>
+                  <a:tcPr>
+                    <a:solidFill>
+                      <a:srgbClr val="0070C0"/>
+                    </a:solidFill>
+                  </a:tcPr>
+                </a:tc>
+                <a:tc>
+                  <a:txBody>
+                    <a:bodyPr/>
+                    <a:lstStyle/>
+                    <a:p>
+                      <a:pPr algn="ctr"/>
+                      <a:r>
+                        <a:rPr lang="en-US" dirty="0"/>
+                        <a:t>Status</a:t>
+                      </a:r>
+                    </a:p>
+                  </a:txBody>
+                  <a:tcPr>
+                    <a:solidFill>
+                      <a:srgbClr val="0070C0"/>
+                    </a:solidFill>
+                  </a:tcPr>
+                </a:tc>
+                <a:extLst>
+                  <a:ext uri="{0D108BD9-81ED-4DB2-BD59-A6C34878D82A}">
+                    <a16:rowId xmlns:a16="http://schemas.microsoft.com/office/drawing/2014/main" val="524030238"/>
+                  </a:ext>
+                </a:extLst>
+              </a:tr>
+              <a:tr h="363062">
+                <a:tc>
+                  <a:txBody>
+                    <a:bodyPr/>
+                    <a:lstStyle/>
+                    <a:p>
+                      <a:pPr algn="ctr"/>
+                      <a:r>
+                        <a:rPr lang="en-US" dirty="0"/>
+                        <a:t>COM-GTRS-01</a:t>
+                      </a:r>
+                    </a:p>
+                  </a:txBody>
+                  <a:tcPr>
+                    <a:solidFill>
+                      <a:srgbClr val="A4C9EB"/>
+                    </a:solidFill>
+                  </a:tcPr>
+                </a:tc>
+                <a:tc>
+                  <a:txBody>
+                    <a:bodyPr/>
+                    <a:lstStyle/>
+                    <a:p>
+                      <a:pPr algn="ctr"/>
+                      <a:r>
+                        <a:rPr lang="en-US" sz="1800" dirty="0"/>
+                        <a:t>EAS 4700 Project Requirements</a:t>
+                      </a:r>
+                    </a:p>
+                  </a:txBody>
+                  <a:tcPr>
+                    <a:solidFill>
+                      <a:srgbClr val="A4C9EB"/>
+                    </a:solidFill>
+                  </a:tcPr>
+                </a:tc>
+                <a:tc>
+                  <a:txBody>
+                    <a:bodyPr/>
+                    <a:lstStyle/>
+                    <a:p>
+                      <a:pPr algn="ctr"/>
+                      <a:r>
+                        <a:rPr lang="en-US" sz="1600" dirty="0"/>
+                        <a:t>Spacecraft Communication System</a:t>
+                      </a:r>
+                    </a:p>
+                  </a:txBody>
+                  <a:tcPr>
+                    <a:solidFill>
+                      <a:srgbClr val="A4C9EB"/>
+                    </a:solidFill>
+                  </a:tcPr>
+                </a:tc>
+                <a:tc>
+                  <a:txBody>
+                    <a:bodyPr/>
+                    <a:lstStyle/>
+                    <a:p>
+                      <a:pPr algn="ctr"/>
+                      <a:r>
+                        <a:rPr lang="en-US" sz="1100" dirty="0"/>
+                        <a:t>The GATOR-SAT </a:t>
+                      </a:r>
+                      <a:r>
+                        <a:rPr lang="en-US" sz="1100" dirty="0" err="1"/>
+                        <a:t>SmallSat</a:t>
+                      </a:r>
+                      <a:r>
+                        <a:rPr lang="en-US" sz="1100" dirty="0"/>
+                        <a:t> should be able to transmit and receive data such as position, health, and desired mission data to and from earth.</a:t>
+                      </a:r>
+                    </a:p>
+                  </a:txBody>
+                  <a:tcPr>
+                    <a:solidFill>
+                      <a:srgbClr val="A4C9EB"/>
+                    </a:solidFill>
+                  </a:tcPr>
+                </a:tc>
+                <a:tc>
+                  <a:txBody>
+                    <a:bodyPr/>
+                    <a:lstStyle/>
+                    <a:p>
+                      <a:pPr algn="ctr"/>
+                      <a:r>
+                        <a:rPr lang="en-US" sz="1100" dirty="0"/>
+                        <a:t>The S-Band antenna gives the transmitter and transceiver the ability to communicate with ground stations.</a:t>
+                      </a:r>
+                    </a:p>
+                  </a:txBody>
+                  <a:tcPr>
+                    <a:solidFill>
+                      <a:srgbClr val="A4C9EB"/>
+                    </a:solidFill>
+                  </a:tcPr>
+                </a:tc>
+                <a:tc>
+                  <a:txBody>
+                    <a:bodyPr/>
+                    <a:lstStyle/>
+                    <a:p>
+                      <a:pPr algn="ctr"/>
+                      <a:endParaRPr lang="en-US" dirty="0"/>
+                    </a:p>
+                  </a:txBody>
+                  <a:tcPr>
+                    <a:solidFill>
+                      <a:srgbClr val="A4C9EB"/>
+                    </a:solidFill>
+                  </a:tcPr>
+                </a:tc>
+                <a:extLst>
+                  <a:ext uri="{0D108BD9-81ED-4DB2-BD59-A6C34878D82A}">
+                    <a16:rowId xmlns:a16="http://schemas.microsoft.com/office/drawing/2014/main" val="2334263199"/>
+                  </a:ext>
+                </a:extLst>
+              </a:tr>
+              <a:tr h="363062">
+                <a:tc>
+                  <a:txBody>
+                    <a:bodyPr/>
+                    <a:lstStyle/>
+                    <a:p>
+                      <a:pPr marL="0" marR="0" lvl="0" indent="0" algn="ctr" defTabSz="914400" rtl="0" eaLnBrk="1" fontAlgn="auto" latinLnBrk="0" hangingPunct="1">
+                        <a:lnSpc>
+                          <a:spcPct val="100000"/>
+                        </a:lnSpc>
+                        <a:spcBef>
+                          <a:spcPts val="0"/>
+                        </a:spcBef>
+                        <a:spcAft>
+                          <a:spcPts val="0"/>
+                        </a:spcAft>
+                        <a:buClrTx/>
+                        <a:buSzTx/>
+                        <a:buFontTx/>
+                        <a:buNone/>
+                        <a:tabLst/>
+                        <a:defRPr/>
+                      </a:pPr>
+                      <a:r>
+                        <a:rPr lang="en-US" dirty="0"/>
+                        <a:t>COM-GTRS-02</a:t>
+                      </a:r>
+                    </a:p>
+                  </a:txBody>
+                  <a:tcPr/>
+                </a:tc>
+                <a:tc>
+                  <a:txBody>
+                    <a:bodyPr/>
+                    <a:lstStyle/>
+                    <a:p>
+                      <a:pPr marL="0" marR="0" lvl="0" indent="0" algn="ctr" defTabSz="914400" rtl="0" eaLnBrk="1" fontAlgn="auto" latinLnBrk="0" hangingPunct="1">
+                        <a:lnSpc>
+                          <a:spcPct val="100000"/>
+                        </a:lnSpc>
+                        <a:spcBef>
+                          <a:spcPts val="0"/>
+                        </a:spcBef>
+                        <a:spcAft>
+                          <a:spcPts val="0"/>
+                        </a:spcAft>
+                        <a:buClrTx/>
+                        <a:buSzTx/>
+                        <a:buFontTx/>
+                        <a:buNone/>
+                        <a:tabLst/>
+                        <a:defRPr/>
+                      </a:pPr>
+                      <a:r>
+                        <a:rPr lang="en-US" sz="1800" dirty="0"/>
+                        <a:t>EAS 4700 Project Requirements</a:t>
+                      </a:r>
+                    </a:p>
+                  </a:txBody>
+                  <a:tcPr/>
+                </a:tc>
+                <a:tc>
+                  <a:txBody>
+                    <a:bodyPr/>
+                    <a:lstStyle/>
+                    <a:p>
+                      <a:pPr algn="ctr"/>
+                      <a:r>
+                        <a:rPr lang="en-US" sz="1600" dirty="0" err="1"/>
+                        <a:t>InterSat</a:t>
+                      </a:r>
+                      <a:r>
+                        <a:rPr lang="en-US" sz="1600" dirty="0"/>
+                        <a:t> Communication System</a:t>
+                      </a:r>
+                    </a:p>
+                  </a:txBody>
+                  <a:tcPr/>
+                </a:tc>
+                <a:tc>
+                  <a:txBody>
+                    <a:bodyPr/>
+                    <a:lstStyle/>
+                    <a:p>
+                      <a:pPr algn="ctr"/>
+                      <a:r>
+                        <a:rPr lang="en-US" sz="1100" dirty="0"/>
+                        <a:t>The GATOR-SAT </a:t>
+                      </a:r>
+                      <a:r>
+                        <a:rPr lang="en-US" sz="1100" dirty="0" err="1"/>
+                        <a:t>SmallSat</a:t>
+                      </a:r>
+                      <a:r>
+                        <a:rPr lang="en-US" sz="1100" dirty="0"/>
+                        <a:t> must be able to send commands and data between the two Sats.</a:t>
+                      </a:r>
+                    </a:p>
+                  </a:txBody>
+                  <a:tcPr/>
+                </a:tc>
+                <a:tc>
+                  <a:txBody>
+                    <a:bodyPr/>
+                    <a:lstStyle/>
+                    <a:p>
+                      <a:pPr algn="ctr"/>
+                      <a:r>
+                        <a:rPr lang="en-US" sz="1100" dirty="0"/>
+                        <a:t>The 915MHz antennas on both </a:t>
+                      </a:r>
+                    </a:p>
+                  </a:txBody>
+                  <a:tcPr/>
+                </a:tc>
+                <a:tc>
+                  <a:txBody>
+                    <a:bodyPr/>
+                    <a:lstStyle/>
+                    <a:p>
+                      <a:pPr algn="ctr"/>
+                      <a:endParaRPr lang="en-US"/>
+                    </a:p>
+                  </a:txBody>
+                  <a:tcPr/>
+                </a:tc>
+                <a:extLst>
+                  <a:ext uri="{0D108BD9-81ED-4DB2-BD59-A6C34878D82A}">
+                    <a16:rowId xmlns:a16="http://schemas.microsoft.com/office/drawing/2014/main" val="3012719692"/>
+                  </a:ext>
+                </a:extLst>
+              </a:tr>
+              <a:tr h="363062">
+                <a:tc>
+                  <a:txBody>
+                    <a:bodyPr/>
+                    <a:lstStyle/>
+                    <a:p>
+                      <a:pPr marL="0" marR="0" lvl="0" indent="0" algn="ctr" defTabSz="914400" rtl="0" eaLnBrk="1" fontAlgn="auto" latinLnBrk="0" hangingPunct="1">
+                        <a:lnSpc>
+                          <a:spcPct val="100000"/>
+                        </a:lnSpc>
+                        <a:spcBef>
+                          <a:spcPts val="0"/>
+                        </a:spcBef>
+                        <a:spcAft>
+                          <a:spcPts val="0"/>
+                        </a:spcAft>
+                        <a:buClrTx/>
+                        <a:buSzTx/>
+                        <a:buFontTx/>
+                        <a:buNone/>
+                        <a:tabLst/>
+                        <a:defRPr/>
+                      </a:pPr>
+                      <a:r>
+                        <a:rPr lang="en-US" dirty="0"/>
+                        <a:t>COM-GTRS-03</a:t>
+                      </a:r>
+                    </a:p>
+                    <a:p>
+                      <a:pPr algn="ctr"/>
+                      <a:endParaRPr lang="en-US" dirty="0"/>
+                    </a:p>
+                  </a:txBody>
+                  <a:tcPr>
+                    <a:solidFill>
+                      <a:srgbClr val="A4C9EB"/>
+                    </a:solidFill>
+                  </a:tcPr>
+                </a:tc>
+                <a:tc>
+                  <a:txBody>
+                    <a:bodyPr/>
+                    <a:lstStyle/>
+                    <a:p>
+                      <a:pPr algn="ctr"/>
+                      <a:r>
+                        <a:rPr lang="en-US" dirty="0"/>
+                        <a:t>COM-GTRS-01</a:t>
+                      </a:r>
+                    </a:p>
+                    <a:p>
+                      <a:pPr algn="ctr"/>
+                      <a:endParaRPr lang="en-US" dirty="0"/>
+                    </a:p>
+                  </a:txBody>
+                  <a:tcPr>
+                    <a:solidFill>
+                      <a:srgbClr val="A4C9EB"/>
+                    </a:solidFill>
+                  </a:tcPr>
+                </a:tc>
+                <a:tc>
+                  <a:txBody>
+                    <a:bodyPr/>
+                    <a:lstStyle/>
+                    <a:p>
+                      <a:pPr algn="ctr"/>
+                      <a:endParaRPr lang="en-US" dirty="0"/>
+                    </a:p>
+                  </a:txBody>
+                  <a:tcPr>
+                    <a:solidFill>
+                      <a:srgbClr val="A4C9EB"/>
+                    </a:solidFill>
+                  </a:tcPr>
+                </a:tc>
+                <a:tc>
+                  <a:txBody>
+                    <a:bodyPr/>
+                    <a:lstStyle/>
+                    <a:p>
+                      <a:pPr algn="ctr"/>
+                      <a:r>
+                        <a:rPr lang="en-US" sz="1100" dirty="0"/>
+                        <a:t>The GATOR-Sat </a:t>
+                      </a:r>
+                      <a:r>
+                        <a:rPr lang="en-US" sz="1100" dirty="0" err="1"/>
+                        <a:t>SmallSat</a:t>
+                      </a:r>
+                      <a:r>
+                        <a:rPr lang="en-US" sz="1100" dirty="0"/>
+                        <a:t> must be able to communicate with ground stations to transmit and receive the data.</a:t>
+                      </a:r>
+                    </a:p>
+                  </a:txBody>
+                  <a:tcPr>
+                    <a:solidFill>
+                      <a:srgbClr val="A4C9EB"/>
+                    </a:solidFill>
+                  </a:tcPr>
+                </a:tc>
+                <a:tc>
+                  <a:txBody>
+                    <a:bodyPr/>
+                    <a:lstStyle/>
+                    <a:p>
+                      <a:pPr algn="ctr"/>
+                      <a:endParaRPr lang="en-US" dirty="0"/>
+                    </a:p>
+                  </a:txBody>
+                  <a:tcPr>
+                    <a:solidFill>
+                      <a:srgbClr val="A4C9EB"/>
+                    </a:solidFill>
+                  </a:tcPr>
+                </a:tc>
+                <a:tc>
+                  <a:txBody>
+                    <a:bodyPr/>
+                    <a:lstStyle/>
+                    <a:p>
+                      <a:pPr algn="ctr"/>
+                      <a:endParaRPr lang="en-US"/>
+                    </a:p>
+                  </a:txBody>
+                  <a:tcPr>
+                    <a:solidFill>
+                      <a:srgbClr val="A4C9EB"/>
+                    </a:solidFill>
+                  </a:tcPr>
+                </a:tc>
+                <a:extLst>
+                  <a:ext uri="{0D108BD9-81ED-4DB2-BD59-A6C34878D82A}">
+                    <a16:rowId xmlns:a16="http://schemas.microsoft.com/office/drawing/2014/main" val="504782230"/>
+                  </a:ext>
+                </a:extLst>
+              </a:tr>
+              <a:tr h="363062">
+                <a:tc>
+                  <a:txBody>
+                    <a:bodyPr/>
+                    <a:lstStyle/>
+                    <a:p>
+                      <a:pPr algn="ctr"/>
+                      <a:endParaRPr lang="en-US"/>
+                    </a:p>
+                  </a:txBody>
+                  <a:tcPr/>
+                </a:tc>
+                <a:tc>
+                  <a:txBody>
+                    <a:bodyPr/>
+                    <a:lstStyle/>
+                    <a:p>
+                      <a:pPr algn="ctr"/>
+                      <a:endParaRPr lang="en-US"/>
+                    </a:p>
+                  </a:txBody>
+                  <a:tcPr/>
+                </a:tc>
+                <a:tc>
+                  <a:txBody>
+                    <a:bodyPr/>
+                    <a:lstStyle/>
+                    <a:p>
+                      <a:pPr algn="ctr"/>
+                      <a:endParaRPr lang="en-US"/>
+                    </a:p>
+                  </a:txBody>
+                  <a:tcPr/>
+                </a:tc>
+                <a:tc>
+                  <a:txBody>
+                    <a:bodyPr/>
+                    <a:lstStyle/>
+                    <a:p>
+                      <a:pPr algn="ctr"/>
+                      <a:endParaRPr lang="en-US"/>
+                    </a:p>
+                  </a:txBody>
+                  <a:tcPr/>
+                </a:tc>
+                <a:tc>
+                  <a:txBody>
+                    <a:bodyPr/>
+                    <a:lstStyle/>
+                    <a:p>
+                      <a:pPr algn="ctr"/>
+                      <a:endParaRPr lang="en-US"/>
+                    </a:p>
+                  </a:txBody>
+                  <a:tcPr/>
+                </a:tc>
+                <a:tc>
+                  <a:txBody>
+                    <a:bodyPr/>
+                    <a:lstStyle/>
+                    <a:p>
+                      <a:pPr algn="ctr"/>
+                      <a:endParaRPr lang="en-US"/>
+                    </a:p>
+                  </a:txBody>
+                  <a:tcPr/>
+                </a:tc>
+                <a:extLst>
+                  <a:ext uri="{0D108BD9-81ED-4DB2-BD59-A6C34878D82A}">
+                    <a16:rowId xmlns:a16="http://schemas.microsoft.com/office/drawing/2014/main" val="723541077"/>
+                  </a:ext>
+                </a:extLst>
+              </a:tr>
+              <a:tr h="363062">
+                <a:tc>
+                  <a:txBody>
+                    <a:bodyPr/>
+                    <a:lstStyle/>
+                    <a:p>
+                      <a:pPr algn="ctr"/>
+                      <a:endParaRPr lang="en-US"/>
+                    </a:p>
+                  </a:txBody>
+                  <a:tcPr>
+                    <a:solidFill>
+                      <a:srgbClr val="A4C9EB"/>
+                    </a:solidFill>
+                  </a:tcPr>
+                </a:tc>
+                <a:tc>
+                  <a:txBody>
+                    <a:bodyPr/>
+                    <a:lstStyle/>
+                    <a:p>
+                      <a:pPr algn="ctr"/>
+                      <a:endParaRPr lang="en-US"/>
+                    </a:p>
+                  </a:txBody>
+                  <a:tcPr>
+                    <a:solidFill>
+                      <a:srgbClr val="A4C9EB"/>
+                    </a:solidFill>
+                  </a:tcPr>
+                </a:tc>
+                <a:tc>
+                  <a:txBody>
+                    <a:bodyPr/>
+                    <a:lstStyle/>
+                    <a:p>
+                      <a:pPr algn="ctr"/>
+                      <a:endParaRPr lang="en-US"/>
+                    </a:p>
+                  </a:txBody>
+                  <a:tcPr>
+                    <a:solidFill>
+                      <a:srgbClr val="A4C9EB"/>
+                    </a:solidFill>
+                  </a:tcPr>
+                </a:tc>
+                <a:tc>
+                  <a:txBody>
+                    <a:bodyPr/>
+                    <a:lstStyle/>
+                    <a:p>
+                      <a:pPr algn="ctr"/>
+                      <a:endParaRPr lang="en-US"/>
+                    </a:p>
+                  </a:txBody>
+                  <a:tcPr>
+                    <a:solidFill>
+                      <a:srgbClr val="A4C9EB"/>
+                    </a:solidFill>
+                  </a:tcPr>
+                </a:tc>
+                <a:tc>
+                  <a:txBody>
+                    <a:bodyPr/>
+                    <a:lstStyle/>
+                    <a:p>
+                      <a:pPr algn="ctr"/>
+                      <a:endParaRPr lang="en-US"/>
+                    </a:p>
+                  </a:txBody>
+                  <a:tcPr>
+                    <a:solidFill>
+                      <a:srgbClr val="A4C9EB"/>
+                    </a:solidFill>
+                  </a:tcPr>
+                </a:tc>
+                <a:tc>
+                  <a:txBody>
+                    <a:bodyPr/>
+                    <a:lstStyle/>
+                    <a:p>
+                      <a:pPr algn="ctr"/>
+                      <a:endParaRPr lang="en-US" dirty="0"/>
+                    </a:p>
+                  </a:txBody>
+                  <a:tcPr>
+                    <a:solidFill>
+                      <a:srgbClr val="A4C9EB"/>
+                    </a:solidFill>
+                  </a:tcPr>
+                </a:tc>
+                <a:extLst>
+                  <a:ext uri="{0D108BD9-81ED-4DB2-BD59-A6C34878D82A}">
+                    <a16:rowId xmlns:a16="http://schemas.microsoft.com/office/drawing/2014/main" val="3232553279"/>
+                  </a:ext>
+                </a:extLst>
+              </a:tr>
+            </a:tbl>
+          </a:graphicData>
+        </a:graphic>
+      </p:graphicFrame>
+    </p:spTree>
+    <p:extLst>
+      <p:ext uri="{BB962C8B-B14F-4D97-AF65-F5344CB8AC3E}">
+        <p14:creationId xmlns:p14="http://schemas.microsoft.com/office/powerpoint/2010/main" val="3739375048"/>
+      </p:ext>
+    </p:extLst>
+  </p:cSld>
+  <p:clrMapOvr>
+    <a:masterClrMapping/>
+  </p:clrMapOvr>
+</p:sld>
+</file>
+
+<file path=ppt/slides/slide6.xml><?xml version="1.0" encoding="utf-8"?>
 <p:sld xmlns:a="http://schemas.openxmlformats.org/drawingml/2006/main" xmlns:r="http://schemas.openxmlformats.org/officeDocument/2006/relationships" xmlns:p="http://schemas.openxmlformats.org/presentationml/2006/main">
   <p:cSld>
     <p:spTree>
@@ -5798,7 +7223,7 @@
           <a:p>
             <a:fld id="{CC057153-B650-4DEB-B370-79DDCFDCE934}" type="slidenum">
               <a:rPr lang="en-US" dirty="0"/>
-              <a:t>5</a:t>
+              <a:t>6</a:t>
             </a:fld>
             <a:endParaRPr lang="en-US"/>
           </a:p>
@@ -5922,7 +7347,7 @@
           <p:nvPr>
             <p:extLst>
               <p:ext uri="{D42A27DB-BD31-4B8C-83A1-F6EECF244321}">
-                <p14:modId xmlns:p14="http://schemas.microsoft.com/office/powerpoint/2010/main" val="334074455"/>
+                <p14:modId xmlns:p14="http://schemas.microsoft.com/office/powerpoint/2010/main" val="346367392"/>
               </p:ext>
             </p:extLst>
           </p:nvPr>
@@ -6079,8 +7504,8 @@
                     <a:lstStyle/>
                     <a:p>
                       <a:r>
-                        <a:rPr lang="en-US"/>
-                        <a:t>ASD-GTRS-01</a:t>
+                        <a:rPr lang="en-US" dirty="0"/>
+                        <a:t>COM-GTRS-01</a:t>
                       </a:r>
                     </a:p>
                   </a:txBody>
@@ -6108,36 +7533,36 @@
                         <a:buNone/>
                       </a:pPr>
                       <a:r>
-                        <a:rPr lang="en-US" sz="1600" b="0" i="0" u="none" strike="noStrike" noProof="0">
+                        <a:rPr lang="en-US" sz="1600" b="0" i="0" u="none" strike="noStrike" noProof="0" dirty="0">
                           <a:latin typeface="Arial"/>
                         </a:rPr>
                         <a:t>The GATOR-SAT </a:t>
                       </a:r>
                       <a:r>
-                        <a:rPr lang="en-US" sz="1600" b="0" i="0" u="none" strike="noStrike" noProof="0" err="1">
+                        <a:rPr lang="en-US" sz="1600" b="0" i="0" u="none" strike="noStrike" noProof="0" dirty="0" err="1">
                           <a:latin typeface="Arial"/>
                         </a:rPr>
                         <a:t>SmallSat</a:t>
                       </a:r>
                       <a:r>
-                        <a:rPr lang="en-US" sz="1600" b="0" i="0" u="none" strike="noStrike" noProof="0">
+                        <a:rPr lang="en-US" sz="1600" b="0" i="0" u="none" strike="noStrike" noProof="0" dirty="0">
                           <a:latin typeface="Arial"/>
                         </a:rPr>
                         <a:t> shall be capable of launching either as a Co-manifested Payload (CPL) or primary payload on a suitable government-owned or commercially owned launch vehicle that can accommodate </a:t>
                       </a:r>
                       <a:r>
-                        <a:rPr lang="en-US" sz="1600" b="0" i="0" u="none" strike="noStrike" noProof="0" err="1">
+                        <a:rPr lang="en-US" sz="1600" b="0" i="0" u="none" strike="noStrike" noProof="0" dirty="0" err="1">
                           <a:latin typeface="Arial"/>
                         </a:rPr>
                         <a:t>SmallSats</a:t>
                       </a:r>
                       <a:r>
-                        <a:rPr lang="en-US" sz="1600" b="0" i="0" u="none" strike="noStrike" noProof="0">
+                        <a:rPr lang="en-US" sz="1600" b="0" i="0" u="none" strike="noStrike" noProof="0" dirty="0">
                           <a:latin typeface="Arial"/>
                         </a:rPr>
                         <a:t>. </a:t>
                       </a:r>
-                      <a:endParaRPr lang="en-US" sz="1600"/>
+                      <a:endParaRPr lang="en-US" sz="1600" dirty="0"/>
                     </a:p>
                   </a:txBody>
                   <a:tcPr>
@@ -6749,7 +8174,7 @@
                       <a:pPr lvl="0">
                         <a:buNone/>
                       </a:pPr>
-                      <a:endParaRPr lang="en-US"/>
+                      <a:endParaRPr lang="en-US" dirty="0"/>
                     </a:p>
                   </a:txBody>
                   <a:tcPr/>
@@ -6782,7 +8207,7 @@
 </p:sld>
 </file>
 
-<file path=ppt/slides/slide6.xml><?xml version="1.0" encoding="utf-8"?>
+<file path=ppt/slides/slide7.xml><?xml version="1.0" encoding="utf-8"?>
 <p:sld xmlns:a="http://schemas.openxmlformats.org/drawingml/2006/main" xmlns:r="http://schemas.openxmlformats.org/officeDocument/2006/relationships" xmlns:p="http://schemas.openxmlformats.org/presentationml/2006/main">
   <p:cSld>
     <p:spTree>
@@ -7028,7 +8453,7 @@
           <a:p>
             <a:fld id="{CC057153-B650-4DEB-B370-79DDCFDCE934}" type="slidenum">
               <a:rPr lang="en-US" dirty="0"/>
-              <a:t>6</a:t>
+              <a:t>7</a:t>
             </a:fld>
             <a:endParaRPr lang="en-US"/>
           </a:p>
@@ -7900,7 +9325,7 @@
 </p:sld>
 </file>
 
-<file path=ppt/slides/slide7.xml><?xml version="1.0" encoding="utf-8"?>
+<file path=ppt/slides/slide8.xml><?xml version="1.0" encoding="utf-8"?>
 <p:sld xmlns:a="http://schemas.openxmlformats.org/drawingml/2006/main" xmlns:r="http://schemas.openxmlformats.org/officeDocument/2006/relationships" xmlns:p="http://schemas.openxmlformats.org/presentationml/2006/main">
   <p:cSld>
     <p:spTree>
@@ -8876,7 +10301,7 @@
           <a:p>
             <a:fld id="{CC057153-B650-4DEB-B370-79DDCFDCE934}" type="slidenum">
               <a:rPr lang="en-US" dirty="0"/>
-              <a:t>7</a:t>
+              <a:t>8</a:t>
             </a:fld>
             <a:endParaRPr lang="en-US"/>
           </a:p>

</xml_diff>